<commit_message>
docs: agrega el guion de las filminas y corrige el stack de pruebas
El guion vive en las notas del orador de cada filmina: que decir, en que
orden y cuanto dura. Los 11 puntos de la rubrica son por la exposicion
oral, no por el archivo, y hasta ahora no habia nada que ensayar el 19.

El reparto de 10 minutos es un objetivo del equipo y queda dicho asi en
las notas: el enunciado no fija duracion, solo "maximo 5 filminas" y
"formato breve y claro".

Corrige ademas el stack de pruebas, que desde el PR #44 incluye Vitest y
seguia diciendo solo JUnit y Playwright en las filminas 3 y 4.

Las capturas de observabilidad quedan como material de respaldo y no
dentro de la filmina 4: son bloques densos de texto de terminal que a
tamano de tarjeta no se leen, y las cinco filminas ya estan llenas.

Co-Authored-By: Claude Opus 5 <noreply@anthropic.com>
</commit_message>
<xml_diff>
--- a/docs/filminas/BudgetWise-5-filminas.pptx
+++ b/docs/filminas/BudgetWise-5-filminas.pptx
@@ -506,7 +506,7 @@
           <a:p>
             <a:r>
               <a:rPr lang="en-US" dirty="0"/>
-              <a:t>Presentar el equipo en 20 segundos y pasar rapido al problema. El objetivo general es textual del enunciado: administrar finanzas basicas de forma clara, organizada y confiable.</a:t>
+              <a:t>GUION — 1 minuto. Habla Pablo. Tiempo total propuesto para toda la presentacion: 10 minutos. El enunciado no fija duracion (solo dice maximo 5 filminas y formato breve y claro), asi que este reparto es un objetivo del equipo. Abrir por el problema, no por el equipo: llevar las cuentas a mano no dice en que se fue el mes. Presentar a los tres en 15 segundos, sin detallar roles. Cerrar con el objetivo, que es textual del enunciado: administrar las finanzas basicas de forma clara, organizada y confiable. No leer la filmina.</a:t>
             </a:r>
             <a:endParaRPr lang="en-US" dirty="0"/>
           </a:p>
@@ -594,7 +594,7 @@
           <a:p>
             <a:r>
               <a:rPr lang="en-US" dirty="0"/>
-              <a:t>Las exclusiones estan en el enunciado y dan puntos: nombrarlas explicitamente muestra que se leyo el alcance. No implementamos nada de la columna derecha, ni siquiera "dejado preparado".</a:t>
+              <a:t>GUION — 1 minuto 30. Habla Pablo. Decir que son ocho funcionalidades y nombrarlas en bloque, sin leerlas una por una. Dedicar la mitad del tiempo a la columna derecha: las exclusiones salen del enunciado y mostrar que se leyeron suma. Frase util: no implementamos nada de esto, ni siquiera dejado preparado. Si preguntan por que no hay integracion bancaria: esta excluida explicitamente por el profesor.</a:t>
             </a:r>
             <a:endParaRPr lang="en-US" dirty="0"/>
           </a:p>
@@ -682,7 +682,7 @@
           <a:p>
             <a:r>
               <a:rPr lang="en-US" dirty="0"/>
-              <a:t>Punto clave: que el saldo, las alertas y el progreso de metas vivan en service/ no es estilo. Es lo que permite probarlos con JUnit sin levantar Spring. Alternativas consideradas en D-01: microservicios, hexagonal y Clean Architecture.</a:t>
+              <a:t>GUION — 2 minutos. Habla Yariel, si se acepta el reparto de la #21. D-01 en una frase: monolito modular en capas, porque el alcance del MVP no justifica servicios distribuidos y los modulos permiten extraer uno mas adelante sin reescribir el dominio. El punto fuerte es por que service/ esta separado: es lo que permite probar el saldo, las alertas y el progreso de metas sin levantar Spring, y de ahi salen 8 puntos de pruebas. Mencionar D-05: se volvio a Spring Boot 3.5.3 a proposito, no por descuido. Si preguntan por que no microservicios, las alternativas consideradas estan en D-01.</a:t>
             </a:r>
             <a:endParaRPr lang="en-US" dirty="0"/>
           </a:p>
@@ -770,7 +770,7 @@
           <a:p>
             <a:r>
               <a:rPr lang="en-US" dirty="0"/>
-              <a:t>El respaldo por reglas de la IA (D-03) es deliberado: no queremos depender de una llamada de red el dia de la exposicion. Si el modelo externo falla, el recomendador por reglas responde igual.</a:t>
+              <a:t>GUION — 2 minutos. Habla Felipe, si se acepta el reparto de la #21. Una frase por tarjeta, sin leerlas. Orden: pruebas, contenerizacion, observabilidad, IA. Material de respaldo para preguntas, que a proposito NO esta en la filmina porque no se leeria: docs/scrum/capturas/observabilidad-metricas.png y observabilidad-logs.png, y los manifiestos de infra/k8s/. Sobre la IA, ser honesto: hay un recomendador por reglas como respaldo (D-03) para no depender de una llamada de red el dia de la demo.</a:t>
             </a:r>
             <a:endParaRPr lang="en-US" dirty="0"/>
           </a:p>
@@ -858,7 +858,7 @@
           <a:p>
             <a:r>
               <a:rPr lang="en-US" dirty="0"/>
-              <a:t>ESTA FILMINA ESTA INCOMPLETA A PROPOSITO. Las tres cifras se llenan al cerrar el Sprint 3; no presentar numeros inventados. La evidencia visual ya tiene dueño: la issue #18 pide guardar captura o video de la corrida E2E para esta filmina, y la #19 pide capturas de logs y metricas. Las capturas de logs y metricas de la #19 ya estan en docs/scrum/capturas/. Falta la de la corrida E2E (#18): reclamarsela a Felipe antes del 22, que cierra el Sprint 3. La entrega es el 23. Ensayar la demo completa con el equipo.</a:t>
+              <a:t>GUION — 3 minutos 30, de los cuales 2:30 son la demo en vivo. Habla Pablo. Primero las cifras, 30 segundos. Despues la demo, siguiendo los seis pasos en orden y sin improvisar. Tener la aplicacion levantada y con sesion iniciada ANTES de empezar: no se arranca docker compose delante del profesor. Plan B si la demo falla: mostrar la captura de la corrida E2E (issue #18). ESTA FILMINA SIGUE INCOMPLETA: las tres cifras se llenan al cerrar el Sprint 3, con datos reales. No presentar numeros inventados. Falta pedirle a Felipe la captura de la #18 antes del 22.</a:t>
             </a:r>
             <a:endParaRPr lang="en-US" dirty="0"/>
           </a:p>
@@ -3904,7 +3904,7 @@
                 <a:ea typeface="Calibri" pitchFamily="34" charset="-122"/>
                 <a:cs typeface="Calibri" pitchFamily="34" charset="-120"/>
               </a:rPr>
-              <a:t>PostgreSQL  ·  Docker Compose  ·  JUnit + Playwright</a:t>
+              <a:t>PostgreSQL  ·  Docker Compose  ·  JUnit + Vitest + Playwright</a:t>
             </a:r>
             <a:endParaRPr lang="en-US" sz="1300" dirty="0"/>
           </a:p>
@@ -4308,7 +4308,7 @@
                 <a:ea typeface="Calibri" pitchFamily="34" charset="-122"/>
                 <a:cs typeface="Calibri" pitchFamily="34" charset="-120"/>
               </a:rPr>
-              <a:t>JUnit sobre service/: saldo, alertas y progreso de metas se prueban sin levantar Spring. Un flujo end-to-end con Playwright: registro, gasto y alerta.</a:t>
+              <a:t>JUnit sobre service/ en el backend y Vitest en el frontend: el saldo, las alertas y el progreso de metas se prueban sin levantar Spring. Un flujo end-to-end con Playwright: registro, gasto y alerta.</a:t>
             </a:r>
             <a:endParaRPr lang="en-US" sz="1250" dirty="0"/>
           </a:p>

</xml_diff>